<commit_message>
add rapport and power BI
</commit_message>
<xml_diff>
--- a/rapport/Soutenance_World_Happiness.pptx
+++ b/rapport/Soutenance_World_Happiness.pptx
@@ -6627,41 +6627,6 @@
               <a:buSzPct val="100000"/>
               <a:buChar char="•"/>
             </a:pPr>
-            <a:r>
-              <a:rPr lang="en-US" sz="1300" dirty="0">
-                <a:solidFill>
-                  <a:srgbClr val="2E2E44"/>
-                </a:solidFill>
-                <a:latin typeface="Calibri" pitchFamily="34" charset="0"/>
-                <a:ea typeface="Calibri" pitchFamily="34" charset="-122"/>
-                <a:cs typeface="Calibri" pitchFamily="34" charset="-120"/>
-              </a:rPr>
-              <a:t>Aucun code ISO dans la source : référentiel géographique à construire.</a:t>
-            </a:r>
-            <a:endParaRPr lang="en-US" sz="1300" dirty="0"/>
-          </a:p>
-          <a:p>
-            <a:pPr marL="342900" indent="-342900">
-              <a:lnSpc>
-                <a:spcPct val="115000"/>
-              </a:lnSpc>
-              <a:spcAft>
-                <a:spcPts val="1000"/>
-              </a:spcAft>
-              <a:buSzPct val="100000"/>
-              <a:buChar char="•"/>
-            </a:pPr>
-            <a:r>
-              <a:rPr lang="en-US" sz="1300" dirty="0">
-                <a:solidFill>
-                  <a:srgbClr val="2E2E44"/>
-                </a:solidFill>
-                <a:latin typeface="Calibri" pitchFamily="34" charset="0"/>
-                <a:ea typeface="Calibri" pitchFamily="34" charset="-122"/>
-                <a:cs typeface="Calibri" pitchFamily="34" charset="-120"/>
-              </a:rPr>
-              <a:t>Un encodage latin-1 non documenté.</a:t>
-            </a:r>
             <a:endParaRPr lang="en-US" sz="1300" dirty="0"/>
           </a:p>
         </p:txBody>

</xml_diff>